<commit_message>
Telegram alerts and commands: telegram.mjs, Connect Telegram in Bot settings, /status /money /positions /watch /pause /resume; owner's chat only, never trades
Co-Authored-By: Claude Opus 5.5 <noreply@anthropic.com>
Claude-Session: https://claude.ai/code/session_01QQfuZEJT49L23nt34ZPzz1
</commit_message>
<xml_diff>
--- a/docs/architecture.pptx
+++ b/docs/architecture.pptx
@@ -2506,7 +2506,7 @@
                   <a:srgbClr val="CADCE6"/>
                 </a:solidFill>
               </a:rPr>
-              <a:t>Version 1.0 · 2026-10-21 · updated with every change</a:t>
+              <a:t>Version 1.1 · 2026-10-23 · updated with every change</a:t>
             </a:r>
             <a:endParaRPr lang="en-US" sz="2000" dirty="0"/>
           </a:p>
@@ -4805,6 +4805,10 @@
             <a:prstDash val="dash"/>
           </a:ln>
         </p:spPr>
+        <p:txBody>
+          <a:bodyPr/>
+          <a:p/>
+        </p:txBody>
       </p:sp>
       <p:sp>
         <p:nvSpPr>
@@ -4868,6 +4872,10 @@
             <a:prstDash val="solid"/>
           </a:ln>
         </p:spPr>
+        <p:txBody>
+          <a:bodyPr/>
+          <a:p/>
+        </p:txBody>
       </p:sp>
       <p:sp>
         <p:nvSpPr>
@@ -4945,6 +4953,10 @@
             <a:prstDash val="solid"/>
           </a:ln>
         </p:spPr>
+        <p:txBody>
+          <a:bodyPr/>
+          <a:p/>
+        </p:txBody>
       </p:sp>
       <p:sp>
         <p:nvSpPr>
@@ -4990,7 +5002,7 @@
                   <a:srgbClr val="17202E"/>
                 </a:solidFill>
               </a:rPr>
-              <a:t>ntfy app</a:t>
+              <a:t>ntfy / Telegram</a:t>
             </a:r>
             <a:endParaRPr lang="en-US" sz="1200" dirty="0"/>
           </a:p>
@@ -5020,6 +5032,10 @@
             <a:prstDash val="dash"/>
           </a:ln>
         </p:spPr>
+        <p:txBody>
+          <a:bodyPr/>
+          <a:p/>
+        </p:txBody>
       </p:sp>
       <p:sp>
         <p:nvSpPr>
@@ -5083,6 +5099,10 @@
             <a:prstDash val="solid"/>
           </a:ln>
         </p:spPr>
+        <p:txBody>
+          <a:bodyPr/>
+          <a:p/>
+        </p:txBody>
       </p:sp>
       <p:sp>
         <p:nvSpPr>
@@ -5160,6 +5180,10 @@
             <a:prstDash val="solid"/>
           </a:ln>
         </p:spPr>
+        <p:txBody>
+          <a:bodyPr/>
+          <a:p/>
+        </p:txBody>
       </p:sp>
       <p:sp>
         <p:nvSpPr>
@@ -5237,6 +5261,10 @@
             <a:prstDash val="solid"/>
           </a:ln>
         </p:spPr>
+        <p:txBody>
+          <a:bodyPr/>
+          <a:p/>
+        </p:txBody>
       </p:sp>
       <p:sp>
         <p:nvSpPr>
@@ -5282,7 +5310,7 @@
                   <a:srgbClr val="FFFFFF"/>
                 </a:solidFill>
               </a:rPr>
-              <a:t>ALPACA_*, JOURNAL_KEY</a:t>
+              <a:t>ALPACA_*, JOURNAL_KEY, TELEGRAM_*</a:t>
             </a:r>
             <a:endParaRPr lang="en-US" sz="1100" dirty="0"/>
           </a:p>
@@ -9389,6 +9417,10 @@
             <a:prstDash val="solid"/>
           </a:ln>
         </p:spPr>
+        <p:txBody>
+          <a:bodyPr/>
+          <a:p/>
+        </p:txBody>
       </p:sp>
       <p:sp>
         <p:nvSpPr>
@@ -9494,6 +9526,10 @@
             <a:prstDash val="solid"/>
           </a:ln>
         </p:spPr>
+        <p:txBody>
+          <a:bodyPr/>
+          <a:p/>
+        </p:txBody>
       </p:sp>
       <p:sp>
         <p:nvSpPr>
@@ -9599,6 +9635,10 @@
             <a:prstDash val="solid"/>
           </a:ln>
         </p:spPr>
+        <p:txBody>
+          <a:bodyPr/>
+          <a:p/>
+        </p:txBody>
       </p:sp>
       <p:sp>
         <p:nvSpPr>
@@ -9704,6 +9744,10 @@
             <a:prstDash val="solid"/>
           </a:ln>
         </p:spPr>
+        <p:txBody>
+          <a:bodyPr/>
+          <a:p/>
+        </p:txBody>
       </p:sp>
       <p:sp>
         <p:nvSpPr>
@@ -9809,6 +9853,10 @@
             <a:prstDash val="solid"/>
           </a:ln>
         </p:spPr>
+        <p:txBody>
+          <a:bodyPr/>
+          <a:p/>
+        </p:txBody>
       </p:sp>
       <p:sp>
         <p:nvSpPr>
@@ -9882,7 +9930,7 @@
                   <a:srgbClr val="17202E"/>
                 </a:solidFill>
               </a:rPr>
-              <a:t>headline classifier</a:t>
+              <a:t>headline classifier · telegram.mjs: alerts + /commands</a:t>
             </a:r>
             <a:endParaRPr lang="en-US" sz="1200" dirty="0"/>
           </a:p>
@@ -9914,6 +9962,10 @@
             <a:prstDash val="solid"/>
           </a:ln>
         </p:spPr>
+        <p:txBody>
+          <a:bodyPr/>
+          <a:p/>
+        </p:txBody>
       </p:sp>
       <p:sp>
         <p:nvSpPr>
@@ -10019,6 +10071,10 @@
             <a:prstDash val="solid"/>
           </a:ln>
         </p:spPr>
+        <p:txBody>
+          <a:bodyPr/>
+          <a:p/>
+        </p:txBody>
       </p:sp>
       <p:sp>
         <p:nvSpPr>
@@ -10146,6 +10202,10 @@
             <a:prstDash val="solid"/>
           </a:ln>
         </p:spPr>
+        <p:txBody>
+          <a:bodyPr/>
+          <a:p/>
+        </p:txBody>
       </p:sp>
       <p:sp>
         <p:nvSpPr>
@@ -10206,6 +10266,10 @@
             <a:tailEnd type="triangle"/>
           </a:ln>
         </p:spPr>
+        <p:txBody>
+          <a:bodyPr/>
+          <a:p/>
+        </p:txBody>
       </p:sp>
       <p:sp>
         <p:nvSpPr>
@@ -10233,6 +10297,10 @@
             <a:prstDash val="solid"/>
           </a:ln>
         </p:spPr>
+        <p:txBody>
+          <a:bodyPr/>
+          <a:p/>
+        </p:txBody>
       </p:sp>
       <p:sp>
         <p:nvSpPr>
@@ -10293,6 +10361,10 @@
             <a:tailEnd type="triangle"/>
           </a:ln>
         </p:spPr>
+        <p:txBody>
+          <a:bodyPr/>
+          <a:p/>
+        </p:txBody>
       </p:sp>
       <p:sp>
         <p:nvSpPr>
@@ -10320,6 +10392,10 @@
             <a:prstDash val="solid"/>
           </a:ln>
         </p:spPr>
+        <p:txBody>
+          <a:bodyPr/>
+          <a:p/>
+        </p:txBody>
       </p:sp>
       <p:sp>
         <p:nvSpPr>
@@ -10380,6 +10456,10 @@
             <a:tailEnd type="triangle"/>
           </a:ln>
         </p:spPr>
+        <p:txBody>
+          <a:bodyPr/>
+          <a:p/>
+        </p:txBody>
       </p:sp>
       <p:sp>
         <p:nvSpPr>
@@ -10407,6 +10487,10 @@
             <a:prstDash val="solid"/>
           </a:ln>
         </p:spPr>
+        <p:txBody>
+          <a:bodyPr/>
+          <a:p/>
+        </p:txBody>
       </p:sp>
       <p:sp>
         <p:nvSpPr>
@@ -10467,6 +10551,10 @@
             <a:tailEnd type="triangle"/>
           </a:ln>
         </p:spPr>
+        <p:txBody>
+          <a:bodyPr/>
+          <a:p/>
+        </p:txBody>
       </p:sp>
       <p:sp>
         <p:nvSpPr>
@@ -10494,6 +10582,10 @@
             <a:prstDash val="solid"/>
           </a:ln>
         </p:spPr>
+        <p:txBody>
+          <a:bodyPr/>
+          <a:p/>
+        </p:txBody>
       </p:sp>
       <p:sp>
         <p:nvSpPr>
@@ -10554,6 +10646,10 @@
             <a:tailEnd type="triangle"/>
           </a:ln>
         </p:spPr>
+        <p:txBody>
+          <a:bodyPr/>
+          <a:p/>
+        </p:txBody>
       </p:sp>
       <p:sp>
         <p:nvSpPr>
@@ -10581,6 +10677,10 @@
             <a:prstDash val="solid"/>
           </a:ln>
         </p:spPr>
+        <p:txBody>
+          <a:bodyPr/>
+          <a:p/>
+        </p:txBody>
       </p:sp>
       <p:sp>
         <p:nvSpPr>
@@ -10641,6 +10741,10 @@
             <a:tailEnd type="triangle"/>
           </a:ln>
         </p:spPr>
+        <p:txBody>
+          <a:bodyPr/>
+          <a:p/>
+        </p:txBody>
       </p:sp>
       <p:sp>
         <p:nvSpPr>
@@ -10668,6 +10772,10 @@
             <a:prstDash val="solid"/>
           </a:ln>
         </p:spPr>
+        <p:txBody>
+          <a:bodyPr/>
+          <a:p/>
+        </p:txBody>
       </p:sp>
       <p:sp>
         <p:nvSpPr>
@@ -10735,7 +10843,7 @@
                   <a:srgbClr val="5B6678"/>
                 </a:solidFill>
               </a:rPr>
-              <a:t>Zero npm dependencies · Node 20+ · 29 unit tests in CI · integration-tested against mock brokers with a fake clock</a:t>
+              <a:t>Zero npm dependencies · Node 20+ · 57 unit tests + 48 order checks in CI · integration-tested against mock brokers with a fake clock</a:t>
             </a:r>
             <a:endParaRPr lang="en-US" sz="1200" dirty="0"/>
           </a:p>

</xml_diff>

<commit_message>
Remove ntfy: Telegram is the only alert channel (page, bot, watchdog, workflows, CSP, tests, docs)
Co-Authored-By: Claude Opus 5.5 <noreply@anthropic.com>
Claude-Session: https://claude.ai/code/session_01QQfuZEJT49L23nt34ZPzz1
</commit_message>
<xml_diff>
--- a/docs/architecture.pptx
+++ b/docs/architecture.pptx
@@ -2536,6 +2536,10 @@
             <a:prstDash val="solid"/>
           </a:ln>
         </p:spPr>
+        <p:txBody>
+          <a:bodyPr/>
+          <a:p/>
+        </p:txBody>
       </p:sp>
       <p:sp>
         <p:nvSpPr>
@@ -3694,7 +3698,7 @@
                   <a:srgbClr val="17202E"/>
                 </a:solidFill>
               </a:rPr>
-              <a:t>Bot trades tab for P/L and risk · Bot settings to change anything (live in 60 s) · Pause / Resume / Run now · ntfy alerts on the phone</a:t>
+              <a:t>Bot trades tab for P/L and risk · Bot settings to change anything (live in 60 s) · Pause / Resume / Run now · Telegram alerts on the phone</a:t>
             </a:r>
             <a:endParaRPr lang="en-US" sz="1150" dirty="0"/>
           </a:p>
@@ -4091,6 +4095,10 @@
             <a:prstDash val="solid"/>
           </a:ln>
         </p:spPr>
+        <p:txBody>
+          <a:bodyPr/>
+          <a:p/>
+        </p:txBody>
       </p:sp>
       <p:sp>
         <p:nvSpPr>
@@ -4224,6 +4232,10 @@
             <a:prstDash val="solid"/>
           </a:ln>
         </p:spPr>
+        <p:txBody>
+          <a:bodyPr/>
+          <a:p/>
+        </p:txBody>
       </p:sp>
       <p:sp>
         <p:nvSpPr>
@@ -4357,6 +4369,10 @@
             <a:prstDash val="solid"/>
           </a:ln>
         </p:spPr>
+        <p:txBody>
+          <a:bodyPr/>
+          <a:p/>
+        </p:txBody>
       </p:sp>
       <p:sp>
         <p:nvSpPr>
@@ -4490,6 +4506,10 @@
             <a:prstDash val="solid"/>
           </a:ln>
         </p:spPr>
+        <p:txBody>
+          <a:bodyPr/>
+          <a:p/>
+        </p:txBody>
       </p:sp>
       <p:sp>
         <p:nvSpPr>
@@ -4625,6 +4645,10 @@
             <a:prstDash val="solid"/>
           </a:ln>
         </p:spPr>
+        <p:txBody>
+          <a:bodyPr/>
+          <a:p/>
+        </p:txBody>
       </p:sp>
       <p:sp>
         <p:nvSpPr>
@@ -5002,7 +5026,7 @@
                   <a:srgbClr val="17202E"/>
                 </a:solidFill>
               </a:rPr>
-              <a:t>ntfy / Telegram</a:t>
+              <a:t>Telegram</a:t>
             </a:r>
             <a:endParaRPr lang="en-US" sz="1200" dirty="0"/>
           </a:p>
@@ -5340,6 +5364,10 @@
             <a:prstDash val="dash"/>
           </a:ln>
         </p:spPr>
+        <p:txBody>
+          <a:bodyPr/>
+          <a:p/>
+        </p:txBody>
       </p:sp>
       <p:sp>
         <p:nvSpPr>
@@ -5403,6 +5431,10 @@
             <a:prstDash val="solid"/>
           </a:ln>
         </p:spPr>
+        <p:txBody>
+          <a:bodyPr/>
+          <a:p/>
+        </p:txBody>
       </p:sp>
       <p:sp>
         <p:nvSpPr>
@@ -5480,6 +5512,10 @@
             <a:prstDash val="solid"/>
           </a:ln>
         </p:spPr>
+        <p:txBody>
+          <a:bodyPr/>
+          <a:p/>
+        </p:txBody>
       </p:sp>
       <p:sp>
         <p:nvSpPr>
@@ -5557,6 +5593,10 @@
             <a:prstDash val="solid"/>
           </a:ln>
         </p:spPr>
+        <p:txBody>
+          <a:bodyPr/>
+          <a:p/>
+        </p:txBody>
       </p:sp>
       <p:sp>
         <p:nvSpPr>
@@ -5632,6 +5672,10 @@
             <a:prstDash val="dash"/>
           </a:ln>
         </p:spPr>
+        <p:txBody>
+          <a:bodyPr/>
+          <a:p/>
+        </p:txBody>
       </p:sp>
       <p:sp>
         <p:nvSpPr>
@@ -5695,6 +5739,10 @@
             <a:prstDash val="solid"/>
           </a:ln>
         </p:spPr>
+        <p:txBody>
+          <a:bodyPr/>
+          <a:p/>
+        </p:txBody>
       </p:sp>
       <p:sp>
         <p:nvSpPr>
@@ -5772,6 +5820,10 @@
             <a:prstDash val="solid"/>
           </a:ln>
         </p:spPr>
+        <p:txBody>
+          <a:bodyPr/>
+          <a:p/>
+        </p:txBody>
       </p:sp>
       <p:sp>
         <p:nvSpPr>
@@ -5849,6 +5901,10 @@
             <a:prstDash val="solid"/>
           </a:ln>
         </p:spPr>
+        <p:txBody>
+          <a:bodyPr/>
+          <a:p/>
+        </p:txBody>
       </p:sp>
       <p:sp>
         <p:nvSpPr>
@@ -5926,6 +5982,10 @@
             <a:prstDash val="solid"/>
           </a:ln>
         </p:spPr>
+        <p:txBody>
+          <a:bodyPr/>
+          <a:p/>
+        </p:txBody>
       </p:sp>
       <p:sp>
         <p:nvSpPr>
@@ -6003,6 +6063,10 @@
             <a:prstDash val="solid"/>
           </a:ln>
         </p:spPr>
+        <p:txBody>
+          <a:bodyPr/>
+          <a:p/>
+        </p:txBody>
       </p:sp>
       <p:sp>
         <p:nvSpPr>
@@ -6034,7 +6098,7 @@
                   <a:srgbClr val="17202E"/>
                 </a:solidFill>
               </a:rPr>
-              <a:t>ntfy.sh</a:t>
+              <a:t>Telegram Bot API</a:t>
             </a:r>
             <a:endParaRPr lang="en-US" sz="1100" dirty="0"/>
           </a:p>
@@ -6077,6 +6141,10 @@
             <a:tailEnd type="triangle"/>
           </a:ln>
         </p:spPr>
+        <p:txBody>
+          <a:bodyPr/>
+          <a:p/>
+        </p:txBody>
       </p:sp>
       <p:sp>
         <p:nvSpPr>
@@ -6139,6 +6207,10 @@
             <a:tailEnd type="triangle"/>
           </a:ln>
         </p:spPr>
+        <p:txBody>
+          <a:bodyPr/>
+          <a:p/>
+        </p:txBody>
       </p:sp>
       <p:sp>
         <p:nvSpPr>
@@ -6201,6 +6273,10 @@
             <a:tailEnd type="triangle"/>
           </a:ln>
         </p:spPr>
+        <p:txBody>
+          <a:bodyPr/>
+          <a:p/>
+        </p:txBody>
       </p:sp>
       <p:sp>
         <p:nvSpPr>
@@ -6225,6 +6301,10 @@
             <a:tailEnd type="triangle"/>
           </a:ln>
         </p:spPr>
+        <p:txBody>
+          <a:bodyPr/>
+          <a:p/>
+        </p:txBody>
       </p:sp>
       <p:sp>
         <p:nvSpPr>
@@ -6287,6 +6367,10 @@
             <a:tailEnd type="triangle"/>
           </a:ln>
         </p:spPr>
+        <p:txBody>
+          <a:bodyPr/>
+          <a:p/>
+        </p:txBody>
       </p:sp>
       <p:sp>
         <p:nvSpPr>
@@ -6349,6 +6433,10 @@
             <a:tailEnd type="triangle"/>
           </a:ln>
         </p:spPr>
+        <p:txBody>
+          <a:bodyPr/>
+          <a:p/>
+        </p:txBody>
       </p:sp>
       <p:sp>
         <p:nvSpPr>
@@ -6411,6 +6499,10 @@
             <a:tailEnd type="triangle"/>
           </a:ln>
         </p:spPr>
+        <p:txBody>
+          <a:bodyPr/>
+          <a:p/>
+        </p:txBody>
       </p:sp>
       <p:sp>
         <p:nvSpPr>
@@ -6473,6 +6565,10 @@
             <a:tailEnd type="triangle"/>
           </a:ln>
         </p:spPr>
+        <p:txBody>
+          <a:bodyPr/>
+          <a:p/>
+        </p:txBody>
       </p:sp>
       <p:sp>
         <p:nvSpPr>
@@ -6497,6 +6593,10 @@
             <a:tailEnd type="triangle"/>
           </a:ln>
         </p:spPr>
+        <p:txBody>
+          <a:bodyPr/>
+          <a:p/>
+        </p:txBody>
       </p:sp>
       <p:sp>
         <p:nvSpPr>
@@ -6521,6 +6621,10 @@
             <a:tailEnd type="triangle"/>
           </a:ln>
         </p:spPr>
+        <p:txBody>
+          <a:bodyPr/>
+          <a:p/>
+        </p:txBody>
       </p:sp>
       <p:sp>
         <p:nvSpPr>
@@ -6583,6 +6687,10 @@
             <a:tailEnd type="triangle"/>
           </a:ln>
         </p:spPr>
+        <p:txBody>
+          <a:bodyPr/>
+          <a:p/>
+        </p:txBody>
       </p:sp>
       <p:sp>
         <p:nvSpPr>
@@ -6752,6 +6860,10 @@
             <a:prstDash val="solid"/>
           </a:ln>
         </p:spPr>
+        <p:txBody>
+          <a:bodyPr/>
+          <a:p/>
+        </p:txBody>
       </p:sp>
       <p:sp>
         <p:nvSpPr>
@@ -6919,6 +7031,10 @@
             <a:prstDash val="solid"/>
           </a:ln>
         </p:spPr>
+        <p:txBody>
+          <a:bodyPr/>
+          <a:p/>
+        </p:txBody>
       </p:sp>
       <p:sp>
         <p:nvSpPr>
@@ -6944,6 +7060,10 @@
             <a:prstDash val="solid"/>
           </a:ln>
         </p:spPr>
+        <p:txBody>
+          <a:bodyPr/>
+          <a:p/>
+        </p:txBody>
       </p:sp>
       <p:sp>
         <p:nvSpPr>
@@ -7111,6 +7231,10 @@
             <a:prstDash val="solid"/>
           </a:ln>
         </p:spPr>
+        <p:txBody>
+          <a:bodyPr/>
+          <a:p/>
+        </p:txBody>
       </p:sp>
       <p:sp>
         <p:nvSpPr>
@@ -7136,6 +7260,10 @@
             <a:prstDash val="solid"/>
           </a:ln>
         </p:spPr>
+        <p:txBody>
+          <a:bodyPr/>
+          <a:p/>
+        </p:txBody>
       </p:sp>
       <p:sp>
         <p:nvSpPr>
@@ -7303,6 +7431,10 @@
             <a:prstDash val="solid"/>
           </a:ln>
         </p:spPr>
+        <p:txBody>
+          <a:bodyPr/>
+          <a:p/>
+        </p:txBody>
       </p:sp>
       <p:sp>
         <p:nvSpPr>
@@ -7328,6 +7460,10 @@
             <a:prstDash val="solid"/>
           </a:ln>
         </p:spPr>
+        <p:txBody>
+          <a:bodyPr/>
+          <a:p/>
+        </p:txBody>
       </p:sp>
       <p:sp>
         <p:nvSpPr>
@@ -7495,6 +7631,10 @@
             <a:prstDash val="solid"/>
           </a:ln>
         </p:spPr>
+        <p:txBody>
+          <a:bodyPr/>
+          <a:p/>
+        </p:txBody>
       </p:sp>
       <p:sp>
         <p:nvSpPr>
@@ -7520,6 +7660,10 @@
             <a:prstDash val="solid"/>
           </a:ln>
         </p:spPr>
+        <p:txBody>
+          <a:bodyPr/>
+          <a:p/>
+        </p:txBody>
       </p:sp>
       <p:sp>
         <p:nvSpPr>
@@ -7687,6 +7831,10 @@
             <a:prstDash val="solid"/>
           </a:ln>
         </p:spPr>
+        <p:txBody>
+          <a:bodyPr/>
+          <a:p/>
+        </p:txBody>
       </p:sp>
       <p:sp>
         <p:nvSpPr>
@@ -7712,6 +7860,10 @@
             <a:prstDash val="solid"/>
           </a:ln>
         </p:spPr>
+        <p:txBody>
+          <a:bodyPr/>
+          <a:p/>
+        </p:txBody>
       </p:sp>
       <p:sp>
         <p:nvSpPr>
@@ -7991,6 +8143,10 @@
             <a:prstDash val="solid"/>
           </a:ln>
         </p:spPr>
+        <p:txBody>
+          <a:bodyPr/>
+          <a:p/>
+        </p:txBody>
       </p:sp>
       <p:sp>
         <p:nvSpPr>
@@ -8054,6 +8210,10 @@
             <a:prstDash val="solid"/>
           </a:ln>
         </p:spPr>
+        <p:txBody>
+          <a:bodyPr/>
+          <a:p/>
+        </p:txBody>
       </p:sp>
       <p:sp>
         <p:nvSpPr>
@@ -8153,6 +8313,10 @@
             <a:prstDash val="solid"/>
           </a:ln>
         </p:spPr>
+        <p:txBody>
+          <a:bodyPr/>
+          <a:p/>
+        </p:txBody>
       </p:sp>
       <p:sp>
         <p:nvSpPr>
@@ -8216,6 +8380,10 @@
             <a:prstDash val="solid"/>
           </a:ln>
         </p:spPr>
+        <p:txBody>
+          <a:bodyPr/>
+          <a:p/>
+        </p:txBody>
       </p:sp>
       <p:sp>
         <p:nvSpPr>
@@ -8279,6 +8447,10 @@
             <a:prstDash val="solid"/>
           </a:ln>
         </p:spPr>
+        <p:txBody>
+          <a:bodyPr/>
+          <a:p/>
+        </p:txBody>
       </p:sp>
       <p:sp>
         <p:nvSpPr>
@@ -8342,6 +8514,10 @@
             <a:prstDash val="solid"/>
           </a:ln>
         </p:spPr>
+        <p:txBody>
+          <a:bodyPr/>
+          <a:p/>
+        </p:txBody>
       </p:sp>
       <p:sp>
         <p:nvSpPr>
@@ -8405,6 +8581,10 @@
             <a:prstDash val="solid"/>
           </a:ln>
         </p:spPr>
+        <p:txBody>
+          <a:bodyPr/>
+          <a:p/>
+        </p:txBody>
       </p:sp>
       <p:sp>
         <p:nvSpPr>
@@ -8468,6 +8648,10 @@
             <a:prstDash val="solid"/>
           </a:ln>
         </p:spPr>
+        <p:txBody>
+          <a:bodyPr/>
+          <a:p/>
+        </p:txBody>
       </p:sp>
       <p:sp>
         <p:nvSpPr>
@@ -8531,6 +8715,10 @@
             <a:prstDash val="solid"/>
           </a:ln>
         </p:spPr>
+        <p:txBody>
+          <a:bodyPr/>
+          <a:p/>
+        </p:txBody>
       </p:sp>
       <p:sp>
         <p:nvSpPr>
@@ -8594,6 +8782,10 @@
             <a:prstDash val="solid"/>
           </a:ln>
         </p:spPr>
+        <p:txBody>
+          <a:bodyPr/>
+          <a:p/>
+        </p:txBody>
       </p:sp>
       <p:sp>
         <p:nvSpPr>
@@ -8657,6 +8849,10 @@
             <a:prstDash val="solid"/>
           </a:ln>
         </p:spPr>
+        <p:txBody>
+          <a:bodyPr/>
+          <a:p/>
+        </p:txBody>
       </p:sp>
       <p:sp>
         <p:nvSpPr>
@@ -8720,6 +8916,10 @@
             <a:prstDash val="solid"/>
           </a:ln>
         </p:spPr>
+        <p:txBody>
+          <a:bodyPr/>
+          <a:p/>
+        </p:txBody>
       </p:sp>
       <p:sp>
         <p:nvSpPr>
@@ -8819,6 +9019,10 @@
             <a:prstDash val="solid"/>
           </a:ln>
         </p:spPr>
+        <p:txBody>
+          <a:bodyPr/>
+          <a:p/>
+        </p:txBody>
       </p:sp>
       <p:sp>
         <p:nvSpPr>
@@ -8910,6 +9114,10 @@
             <a:prstDash val="solid"/>
           </a:ln>
         </p:spPr>
+        <p:txBody>
+          <a:bodyPr/>
+          <a:p/>
+        </p:txBody>
       </p:sp>
       <p:sp>
         <p:nvSpPr>
@@ -9001,6 +9209,10 @@
             <a:prstDash val="solid"/>
           </a:ln>
         </p:spPr>
+        <p:txBody>
+          <a:bodyPr/>
+          <a:p/>
+        </p:txBody>
       </p:sp>
       <p:sp>
         <p:nvSpPr>
@@ -9078,6 +9290,10 @@
             <a:prstDash val="solid"/>
           </a:ln>
         </p:spPr>
+        <p:txBody>
+          <a:bodyPr/>
+          <a:p/>
+        </p:txBody>
       </p:sp>
       <p:sp>
         <p:nvSpPr>
@@ -9155,6 +9371,10 @@
             <a:prstDash val="solid"/>
           </a:ln>
         </p:spPr>
+        <p:txBody>
+          <a:bodyPr/>
+          <a:p/>
+        </p:txBody>
       </p:sp>
       <p:sp>
         <p:nvSpPr>
@@ -9232,6 +9452,10 @@
             <a:prstDash val="solid"/>
           </a:ln>
         </p:spPr>
+        <p:txBody>
+          <a:bodyPr/>
+          <a:p/>
+        </p:txBody>
       </p:sp>
       <p:sp>
         <p:nvSpPr>
@@ -11019,6 +11243,10 @@
             <a:prstDash val="solid"/>
           </a:ln>
         </p:spPr>
+        <p:txBody>
+          <a:bodyPr/>
+          <a:p/>
+        </p:txBody>
       </p:sp>
       <p:sp>
         <p:nvSpPr>
@@ -11096,6 +11324,10 @@
             <a:prstDash val="solid"/>
           </a:ln>
         </p:spPr>
+        <p:txBody>
+          <a:bodyPr/>
+          <a:p/>
+        </p:txBody>
       </p:sp>
       <p:sp>
         <p:nvSpPr>
@@ -11173,6 +11405,10 @@
             <a:prstDash val="solid"/>
           </a:ln>
         </p:spPr>
+        <p:txBody>
+          <a:bodyPr/>
+          <a:p/>
+        </p:txBody>
       </p:sp>
       <p:sp>
         <p:nvSpPr>
@@ -11250,6 +11486,10 @@
             <a:prstDash val="solid"/>
           </a:ln>
         </p:spPr>
+        <p:txBody>
+          <a:bodyPr/>
+          <a:p/>
+        </p:txBody>
       </p:sp>
       <p:sp>
         <p:nvSpPr>
@@ -11327,6 +11567,10 @@
             <a:prstDash val="solid"/>
           </a:ln>
         </p:spPr>
+        <p:txBody>
+          <a:bodyPr/>
+          <a:p/>
+        </p:txBody>
       </p:sp>
       <p:sp>
         <p:nvSpPr>
@@ -11404,6 +11648,10 @@
             <a:prstDash val="solid"/>
           </a:ln>
         </p:spPr>
+        <p:txBody>
+          <a:bodyPr/>
+          <a:p/>
+        </p:txBody>
       </p:sp>
       <p:sp>
         <p:nvSpPr>
@@ -11509,6 +11757,10 @@
             <a:prstDash val="solid"/>
           </a:ln>
         </p:spPr>
+        <p:txBody>
+          <a:bodyPr/>
+          <a:p/>
+        </p:txBody>
       </p:sp>
       <p:sp>
         <p:nvSpPr>
@@ -11586,6 +11838,10 @@
             <a:prstDash val="solid"/>
           </a:ln>
         </p:spPr>
+        <p:txBody>
+          <a:bodyPr/>
+          <a:p/>
+        </p:txBody>
       </p:sp>
       <p:sp>
         <p:nvSpPr>
@@ -11663,6 +11919,10 @@
             <a:prstDash val="solid"/>
           </a:ln>
         </p:spPr>
+        <p:txBody>
+          <a:bodyPr/>
+          <a:p/>
+        </p:txBody>
       </p:sp>
       <p:sp>
         <p:nvSpPr>
@@ -11740,6 +12000,10 @@
             <a:prstDash val="solid"/>
           </a:ln>
         </p:spPr>
+        <p:txBody>
+          <a:bodyPr/>
+          <a:p/>
+        </p:txBody>
       </p:sp>
       <p:sp>
         <p:nvSpPr>
@@ -11817,6 +12081,10 @@
             <a:prstDash val="solid"/>
           </a:ln>
         </p:spPr>
+        <p:txBody>
+          <a:bodyPr/>
+          <a:p/>
+        </p:txBody>
       </p:sp>
       <p:sp>
         <p:nvSpPr>
@@ -11848,7 +12116,7 @@
                   <a:srgbClr val="17202E"/>
                 </a:solidFill>
               </a:rPr>
-              <a:t>ntfy</a:t>
+              <a:t>Telegram</a:t>
             </a:r>
             <a:endParaRPr lang="en-US" sz="1200" dirty="0"/>
           </a:p>
@@ -11891,6 +12159,10 @@
             <a:tailEnd type="triangle"/>
           </a:ln>
         </p:spPr>
+        <p:txBody>
+          <a:bodyPr/>
+          <a:p/>
+        </p:txBody>
       </p:sp>
       <p:sp>
         <p:nvSpPr>
@@ -11953,6 +12225,10 @@
             <a:tailEnd type="triangle"/>
           </a:ln>
         </p:spPr>
+        <p:txBody>
+          <a:bodyPr/>
+          <a:p/>
+        </p:txBody>
       </p:sp>
       <p:sp>
         <p:nvSpPr>
@@ -11977,6 +12253,10 @@
             <a:tailEnd type="triangle"/>
           </a:ln>
         </p:spPr>
+        <p:txBody>
+          <a:bodyPr/>
+          <a:p/>
+        </p:txBody>
       </p:sp>
       <p:sp>
         <p:nvSpPr>
@@ -12001,6 +12281,10 @@
             <a:tailEnd type="triangle"/>
           </a:ln>
         </p:spPr>
+        <p:txBody>
+          <a:bodyPr/>
+          <a:p/>
+        </p:txBody>
       </p:sp>
       <p:sp>
         <p:nvSpPr>
@@ -12063,6 +12347,10 @@
             <a:tailEnd type="triangle"/>
           </a:ln>
         </p:spPr>
+        <p:txBody>
+          <a:bodyPr/>
+          <a:p/>
+        </p:txBody>
       </p:sp>
       <p:sp>
         <p:nvSpPr>
@@ -12087,6 +12375,10 @@
             <a:tailEnd type="triangle"/>
           </a:ln>
         </p:spPr>
+        <p:txBody>
+          <a:bodyPr/>
+          <a:p/>
+        </p:txBody>
       </p:sp>
       <p:sp>
         <p:nvSpPr>
@@ -12149,6 +12441,10 @@
             <a:tailEnd type="triangle"/>
           </a:ln>
         </p:spPr>
+        <p:txBody>
+          <a:bodyPr/>
+          <a:p/>
+        </p:txBody>
       </p:sp>
       <p:sp>
         <p:nvSpPr>
@@ -12173,6 +12469,10 @@
             <a:tailEnd type="triangle"/>
           </a:ln>
         </p:spPr>
+        <p:txBody>
+          <a:bodyPr/>
+          <a:p/>
+        </p:txBody>
       </p:sp>
       <p:sp>
         <p:nvSpPr>
@@ -12235,6 +12535,10 @@
             <a:tailEnd type="triangle"/>
           </a:ln>
         </p:spPr>
+        <p:txBody>
+          <a:bodyPr/>
+          <a:p/>
+        </p:txBody>
       </p:sp>
       <p:sp>
         <p:nvSpPr>
@@ -12259,6 +12563,10 @@
             <a:tailEnd type="triangle"/>
           </a:ln>
         </p:spPr>
+        <p:txBody>
+          <a:bodyPr/>
+          <a:p/>
+        </p:txBody>
       </p:sp>
       <p:sp>
         <p:nvSpPr>
@@ -12286,6 +12594,10 @@
             <a:prstDash val="solid"/>
           </a:ln>
         </p:spPr>
+        <p:txBody>
+          <a:bodyPr/>
+          <a:p/>
+        </p:txBody>
       </p:sp>
       <p:sp>
         <p:nvSpPr>
@@ -13083,6 +13395,10 @@
             <a:prstDash val="dash"/>
           </a:ln>
         </p:spPr>
+        <p:txBody>
+          <a:bodyPr/>
+          <a:p/>
+        </p:txBody>
       </p:sp>
       <p:sp>
         <p:nvSpPr>
@@ -13146,6 +13462,10 @@
             <a:prstDash val="solid"/>
           </a:ln>
         </p:spPr>
+        <p:txBody>
+          <a:bodyPr/>
+          <a:p/>
+        </p:txBody>
       </p:sp>
       <p:sp>
         <p:nvSpPr>
@@ -13209,6 +13529,10 @@
             <a:prstDash val="solid"/>
           </a:ln>
         </p:spPr>
+        <p:txBody>
+          <a:bodyPr/>
+          <a:p/>
+        </p:txBody>
       </p:sp>
       <p:sp>
         <p:nvSpPr>
@@ -13272,6 +13596,10 @@
             <a:prstDash val="solid"/>
           </a:ln>
         </p:spPr>
+        <p:txBody>
+          <a:bodyPr/>
+          <a:p/>
+        </p:txBody>
       </p:sp>
       <p:sp>
         <p:nvSpPr>
@@ -13335,6 +13663,10 @@
             <a:prstDash val="solid"/>
           </a:ln>
         </p:spPr>
+        <p:txBody>
+          <a:bodyPr/>
+          <a:p/>
+        </p:txBody>
       </p:sp>
       <p:sp>
         <p:nvSpPr>
@@ -13410,6 +13742,10 @@
             <a:prstDash val="dash"/>
           </a:ln>
         </p:spPr>
+        <p:txBody>
+          <a:bodyPr/>
+          <a:p/>
+        </p:txBody>
       </p:sp>
       <p:sp>
         <p:nvSpPr>
@@ -13473,6 +13809,10 @@
             <a:prstDash val="solid"/>
           </a:ln>
         </p:spPr>
+        <p:txBody>
+          <a:bodyPr/>
+          <a:p/>
+        </p:txBody>
       </p:sp>
       <p:sp>
         <p:nvSpPr>
@@ -13536,6 +13876,10 @@
             <a:prstDash val="solid"/>
           </a:ln>
         </p:spPr>
+        <p:txBody>
+          <a:bodyPr/>
+          <a:p/>
+        </p:txBody>
       </p:sp>
       <p:sp>
         <p:nvSpPr>
@@ -13599,6 +13943,10 @@
             <a:prstDash val="solid"/>
           </a:ln>
         </p:spPr>
+        <p:txBody>
+          <a:bodyPr/>
+          <a:p/>
+        </p:txBody>
       </p:sp>
       <p:sp>
         <p:nvSpPr>
@@ -13662,6 +14010,10 @@
             <a:prstDash val="solid"/>
           </a:ln>
         </p:spPr>
+        <p:txBody>
+          <a:bodyPr/>
+          <a:p/>
+        </p:txBody>
       </p:sp>
       <p:sp>
         <p:nvSpPr>
@@ -13723,6 +14075,10 @@
             <a:prstDash val="dash"/>
           </a:ln>
         </p:spPr>
+        <p:txBody>
+          <a:bodyPr/>
+          <a:p/>
+        </p:txBody>
       </p:sp>
       <p:sp>
         <p:nvSpPr>
@@ -13786,6 +14142,10 @@
             <a:prstDash val="solid"/>
           </a:ln>
         </p:spPr>
+        <p:txBody>
+          <a:bodyPr/>
+          <a:p/>
+        </p:txBody>
       </p:sp>
       <p:sp>
         <p:nvSpPr>
@@ -13849,6 +14209,10 @@
             <a:prstDash val="solid"/>
           </a:ln>
         </p:spPr>
+        <p:txBody>
+          <a:bodyPr/>
+          <a:p/>
+        </p:txBody>
       </p:sp>
       <p:sp>
         <p:nvSpPr>
@@ -13912,6 +14276,10 @@
             <a:prstDash val="solid"/>
           </a:ln>
         </p:spPr>
+        <p:txBody>
+          <a:bodyPr/>
+          <a:p/>
+        </p:txBody>
       </p:sp>
       <p:sp>
         <p:nvSpPr>
@@ -13975,6 +14343,10 @@
             <a:prstDash val="solid"/>
           </a:ln>
         </p:spPr>
+        <p:txBody>
+          <a:bodyPr/>
+          <a:p/>
+        </p:txBody>
       </p:sp>
       <p:sp>
         <p:nvSpPr>
@@ -14006,7 +14378,7 @@
                   <a:srgbClr val="FFFFFF"/>
                 </a:solidFill>
               </a:rPr>
-              <a:t>NTFY_TOPIC</a:t>
+              <a:t>TELEGRAM_*</a:t>
             </a:r>
             <a:endParaRPr lang="en-US" sz="1100" dirty="0"/>
           </a:p>
@@ -14035,6 +14407,10 @@
             <a:tailEnd type="triangle"/>
           </a:ln>
         </p:spPr>
+        <p:txBody>
+          <a:bodyPr/>
+          <a:p/>
+        </p:txBody>
       </p:sp>
       <p:sp>
         <p:nvSpPr>
@@ -14104,7 +14480,7 @@
                   <a:srgbClr val="5B6678"/>
                 </a:solidFill>
               </a:rPr>
-              <a:t>Live trading needs live keys + Mode = Live + a typed confirmation. API keys can trade but not withdraw. Only third-party script is hash-pinned; Actions pinned to commit SHAs; zero npm dependencies. Owner checklist in SECURITY.md: 2FA everywhere, sole collaborator, 90-day token, random ntfy topic, never paste keys.</a:t>
+              <a:t>Live trading needs live keys + Mode = Live + a typed confirmation. API keys can trade but not withdraw. Only third-party script is hash-pinned; Actions pinned to commit SHAs; zero npm dependencies. Owner checklist in SECURITY.md: 2FA everywhere, sole collaborator, 90-day token, Telegram via the page only, never paste keys.</a:t>
             </a:r>
             <a:endParaRPr lang="en-US" sz="1100" dirty="0"/>
           </a:p>

</xml_diff>